<commit_message>
Name the RL seams by component instead of source file
</commit_message>
<xml_diff>
--- a/slides/adversarial_rl_page.pptx
+++ b/slides/adversarial_rl_page.pptx
@@ -5985,15 +5985,26 @@
               </a:spcAft>
             </a:pPr>
             <a:r>
-              <a:rPr sz="800" b="1">
+              <a:rPr sz="850" b="1">
                 <a:solidFill>
                   <a:srgbClr val="FFFFFF"/>
                 </a:solidFill>
+                <a:latin typeface="Microsoft YaHei"/>
+                <a:ea typeface="Microsoft YaHei"/>
+                <a:cs typeface="Microsoft YaHei"/>
+              </a:rPr>
+              <a:t>策略接口</a:t>
+            </a:r>
+            <a:r>
+              <a:rPr sz="700" b="0">
+                <a:solidFill>
+                  <a:srgbClr val="FFFFFF"/>
+                </a:solidFill>
                 <a:latin typeface="Consolas"/>
                 <a:ea typeface="Microsoft YaHei"/>
                 <a:cs typeface="Microsoft YaHei"/>
               </a:rPr>
-              <a:t>policy.py</a:t>
+              <a:t>　Policy</a:t>
             </a:r>
           </a:p>
         </p:txBody>
@@ -6036,11 +6047,11 @@
                 <a:solidFill>
                   <a:srgbClr val="0A2B45"/>
                 </a:solidFill>
-                <a:latin typeface="Consolas"/>
-                <a:ea typeface="Microsoft YaHei"/>
-                <a:cs typeface="Microsoft YaHei"/>
-              </a:rPr>
-              <a:t>Policy.sample(prompt, n, T)</a:t>
+                <a:latin typeface="Microsoft YaHei"/>
+                <a:ea typeface="Microsoft YaHei"/>
+                <a:cs typeface="Microsoft YaHei"/>
+              </a:rPr>
+              <a:t>sample(规格, N, 温度) → 候选</a:t>
             </a:r>
           </a:p>
           <a:p>
@@ -6196,15 +6207,26 @@
               </a:spcAft>
             </a:pPr>
             <a:r>
-              <a:rPr sz="800" b="1">
+              <a:rPr sz="850" b="1">
                 <a:solidFill>
                   <a:srgbClr val="FFFFFF"/>
                 </a:solidFill>
+                <a:latin typeface="Microsoft YaHei"/>
+                <a:ea typeface="Microsoft YaHei"/>
+                <a:cs typeface="Microsoft YaHei"/>
+              </a:rPr>
+              <a:t>分组采样</a:t>
+            </a:r>
+            <a:r>
+              <a:rPr sz="700" b="0">
+                <a:solidFill>
+                  <a:srgbClr val="FFFFFF"/>
+                </a:solidFill>
                 <a:latin typeface="Consolas"/>
                 <a:ea typeface="Microsoft YaHei"/>
                 <a:cs typeface="Microsoft YaHei"/>
               </a:rPr>
-              <a:t>loop.py</a:t>
+              <a:t>　Group</a:t>
             </a:r>
           </a:p>
         </p:txBody>
@@ -6247,11 +6269,11 @@
                 <a:solidFill>
                   <a:srgbClr val="0A2B45"/>
                 </a:solidFill>
-                <a:latin typeface="Consolas"/>
-                <a:ea typeface="Microsoft YaHei"/>
-                <a:cs typeface="Microsoft YaHei"/>
-              </a:rPr>
-              <a:t>--n-candidates N</a:t>
+                <a:latin typeface="Microsoft YaHei"/>
+                <a:ea typeface="Microsoft YaHei"/>
+                <a:cs typeface="Microsoft YaHei"/>
+              </a:rPr>
+              <a:t>每轮 N 个候选（当前 N=1）</a:t>
             </a:r>
           </a:p>
           <a:p>
@@ -6429,15 +6451,26 @@
               </a:spcAft>
             </a:pPr>
             <a:r>
-              <a:rPr sz="800" b="1">
+              <a:rPr sz="850" b="1">
                 <a:solidFill>
                   <a:srgbClr val="FFFFFF"/>
                 </a:solidFill>
+                <a:latin typeface="Microsoft YaHei"/>
+                <a:ea typeface="Microsoft YaHei"/>
+                <a:cs typeface="Microsoft YaHei"/>
+              </a:rPr>
+              <a:t>奖励函数</a:t>
+            </a:r>
+            <a:r>
+              <a:rPr sz="700" b="0">
+                <a:solidFill>
+                  <a:srgbClr val="FFFFFF"/>
+                </a:solidFill>
                 <a:latin typeface="Consolas"/>
                 <a:ea typeface="Microsoft YaHei"/>
                 <a:cs typeface="Microsoft YaHei"/>
               </a:rPr>
-              <a:t>reward.py</a:t>
+              <a:t>　Reward</a:t>
             </a:r>
           </a:p>
         </p:txBody>
@@ -6480,11 +6513,11 @@
                 <a:solidFill>
                   <a:srgbClr val="0A2B45"/>
                 </a:solidFill>
-                <a:latin typeface="Consolas"/>
-                <a:ea typeface="Microsoft YaHei"/>
-                <a:cs typeface="Microsoft YaHei"/>
-              </a:rPr>
-              <a:t>harness 结果 → 奖励 + 优势</a:t>
+                <a:latin typeface="Microsoft YaHei"/>
+                <a:ea typeface="Microsoft YaHei"/>
+                <a:cs typeface="Microsoft YaHei"/>
+              </a:rPr>
+              <a:t>Harness 判决 → 奖励 + 组内优势</a:t>
             </a:r>
           </a:p>
           <a:p>
@@ -6662,15 +6695,26 @@
               </a:spcAft>
             </a:pPr>
             <a:r>
-              <a:rPr sz="800" b="1">
+              <a:rPr sz="850" b="1">
                 <a:solidFill>
                   <a:srgbClr val="FFFFFF"/>
                 </a:solidFill>
+                <a:latin typeface="Microsoft YaHei"/>
+                <a:ea typeface="Microsoft YaHei"/>
+                <a:cs typeface="Microsoft YaHei"/>
+              </a:rPr>
+              <a:t>轨迹记录</a:t>
+            </a:r>
+            <a:r>
+              <a:rPr sz="700" b="0">
+                <a:solidFill>
+                  <a:srgbClr val="FFFFFF"/>
+                </a:solidFill>
                 <a:latin typeface="Consolas"/>
                 <a:ea typeface="Microsoft YaHei"/>
                 <a:cs typeface="Microsoft YaHei"/>
               </a:rPr>
-              <a:t>trajectory.py</a:t>
+              <a:t>　Rollout</a:t>
             </a:r>
           </a:p>
         </p:txBody>
@@ -6713,11 +6757,11 @@
                 <a:solidFill>
                   <a:srgbClr val="0A2B45"/>
                 </a:solidFill>
-                <a:latin typeface="Consolas"/>
-                <a:ea typeface="Microsoft YaHei"/>
-                <a:cs typeface="Microsoft YaHei"/>
-              </a:rPr>
-              <a:t>results/rollouts.jsonl</a:t>
+                <a:latin typeface="Microsoft YaHei"/>
+                <a:ea typeface="Microsoft YaHei"/>
+                <a:cs typeface="Microsoft YaHei"/>
+              </a:rPr>
+              <a:t>每组记 规格 · 候选 · 奖励 · 优势</a:t>
             </a:r>
           </a:p>
           <a:p>
@@ -6741,7 +6785,7 @@
                 <a:ea typeface="Microsoft YaHei"/>
                 <a:cs typeface="Microsoft YaHei"/>
               </a:rPr>
-              <a:t>prompt · candidates · reward · advantage</a:t>
+              <a:t>训练循环直接消费这份数据</a:t>
             </a:r>
           </a:p>
         </p:txBody>

</xml_diff>